<commit_message>
Refresh deliverables for full-census + full-text corpus
Updated the draft deck, executive summary (HTML+PDF), and figures to cite
the refreshed numbers:
- AoU corpus 1,378 -> 1,428 substantive pubs
- Peer biobanks now full census: UKB 11,868, FinnGen 3,152, MVP 438, CKB 558
- 19 theme shares, focus-area shares, hot-area counts (HA4 33 AI pubs, etc.)
- Dermatology peer index 7.8x -> 6.9x; pre/post-2023 ratio 7.8x -> 8.1x
- ELSI over-index 21x -> 26x
- Aging/ADRD softened: AoU now ~peer median (0.84x), growing (+4.7) but
  trailing UKB's +6.9 surge -- the CC-5 gap is narrowing, not flat. Weaker-
  evidence flag than the prior draft.
- Regenerated figures (corpus_by_year, peer_under_indexed, distinctive_
  strengths) and rebuilt PPTX + exec-summary PDF (headless Chrome).

data_types_inventory.html/PDF unchanged (no corpus/peer counts).

Co-Authored-By: Claude Opus 4.8 <noreply@anthropic.com>
</commit_message>
<xml_diff>
--- a/resources/deliverables/AoU_Roadmap_Refresh_Draft_Deck.pptx
+++ b/resources/deliverables/AoU_Roadmap_Refresh_Draft_Deck.pptx
@@ -720,7 +720,7 @@
               <a:rPr sz="1000">
                 <a:latin typeface="Helvetica"/>
               </a:rPr>
-              <a:t>Under-indexed (left chart): multi-omics 1.7% vs UKB 10%, imaging 0.6% vs UKB 8.1%, microbiome 0.8% vs FinnGen 14%, rare disease 3.9% vs UKB 17%, aging 4.2% vs UKB 14.9%.</a:t>
+              <a:t>Under-indexed (left chart): multi-omics 1.7% vs UKB 10%, imaging 0.6% vs UKB 8.0%, microbiome 0.8% vs FinnGen 14%, rare disease 3.8% vs UKB 18%, aging 5.5% vs UKB 15.7%.</a:t>
             </a:r>
           </a:p>
           <a:p>
@@ -728,7 +728,7 @@
               <a:rPr sz="1000">
                 <a:latin typeface="Helvetica"/>
               </a:rPr>
-              <a:t>Over-indexed (right chart): ELSI 21.2× peer median, SDOH 5.1×, PGx 4.6×, methods 3.0×. These are AoU's DEFENSIBLE IDENTITY — distinctive strengths the Refresh must preserve.</a:t>
+              <a:t>Over-indexed (right chart): ELSI 26.3× peer median, SDOH 5.1×, PGx 4.6×, methods 3.0×. These are AoU's DEFENSIBLE IDENTITY — distinctive strengths the Refresh must preserve.</a:t>
             </a:r>
           </a:p>
           <a:p>
@@ -736,7 +736,7 @@
               <a:rPr sz="1000">
                 <a:latin typeface="Helvetica"/>
               </a:rPr>
-              <a:t>Caveats: PubMed-name-search has known undercount (especially MVP); pre-2023 baseline is small (157 AoU pubs); use STATIC SHARE INDEX, not trend differentials. Dermatology 7.8× over-index is an artifact (1-2 prolific groups).</a:t>
+              <a:t>Caveats: PubMed-name-search has known undercount (especially MVP); pre-2023 baseline is small (157 AoU pubs); use STATIC SHARE INDEX, not trend differentials. Dermatology 6.9× over-index is an artifact (1-2 prolific groups).</a:t>
             </a:r>
           </a:p>
         </p:txBody>
@@ -817,7 +817,7 @@
               <a:rPr sz="1000">
                 <a:latin typeface="Helvetica"/>
               </a:rPr>
-              <a:t>Rec 1 (3.71 mean): 'Add a Data, AI &amp; Methods focus area.' 18% corpus orphan; HA4 31 AI pubs; NLM-G1 explicit alignment. Risk: Sci Com may prefer reorganization to addition; defend with the empirical orphan count.</a:t>
+              <a:t>Rec 1 (3.71 mean): 'Add a Data, AI &amp; Methods focus area.' 18% corpus orphan; HA4 33 AI pubs; NLM-G1 explicit alignment. Risk: Sci Com may prefer reorganization to addition; defend with the empirical orphan count.</a:t>
             </a:r>
           </a:p>
           <a:p>
@@ -1213,7 +1213,7 @@
               <a:rPr sz="1000">
                 <a:latin typeface="Helvetica"/>
               </a:rPr>
-              <a:t>Rec 2 (3.60): the four-strength narrative is the MOST EVIDENCE-DRIVEN recommendation in any WG — peer-index numbers are precise from the corpus analysis. Distinctive ≠ growing; the headline rests on these four genuine over-indexes. Dermatology 7.8× over-index is an artifact (rehearsed answer required).</a:t>
+              <a:t>Rec 2 (3.60): the four-strength narrative is the MOST EVIDENCE-DRIVEN recommendation in any WG — peer-index numbers are precise from the corpus analysis. Distinctive ≠ growing; the headline rests on these four genuine over-indexes. Dermatology 6.9× over-index is an artifact (rehearsed answer required).</a:t>
             </a:r>
           </a:p>
           <a:p>
@@ -1310,7 +1310,7 @@
               <a:rPr sz="1000">
                 <a:latin typeface="Helvetica"/>
               </a:rPr>
-              <a:t>CC-5 (Aging/ADRD) is the most important flag because no Top-3 currently owns it. AoU is flat at 4.2% post-2023 while every peer biobank surges in the lecanemab/donanemab era. Structural advantage (EHR + UBR diversity) but under-utilization. NIA engagement workstream is the natural answer; outside any current Top-3.</a:t>
+              <a:t>CC-5 (Aging/ADRD) is a flag because no Top-3 currently owns it. AoU is at 6.0% post-2023 (≈peer median, index 0.84×) and growing (+4.7), but still trailing UKB's +6.9 surge in the lecanemab/donanemab era. Structural advantage (EHR + UBR diversity); the gap is narrowing rather than flat, so this is now a weaker-evidence flag than in the prior draft. NIA engagement workstream is the natural answer; outside any current Top-3.</a:t>
             </a:r>
           </a:p>
         </p:txBody>
@@ -1391,7 +1391,7 @@
               <a:rPr sz="1000">
                 <a:latin typeface="Helvetica"/>
               </a:rPr>
-              <a:t>The dermatology caveat is NON-NEGOTIABLE to include — if Sci Com or external audiences see 'dermatology peer-index 7.8×' without context, they may push to elevate dermatology, which would mislead the Roadmap. Phase 1 README flagged the 1-2-prolific-groups origin; Phase 3b temporal trends show declining share.</a:t>
+              <a:t>The dermatology caveat is NON-NEGOTIABLE to include — if Sci Com or external audiences see 'dermatology peer-index 6.9×' without context, they may push to elevate dermatology, which would mislead the Roadmap. Phase 1 README flagged the 1-2-prolific-groups origin; Phase 3b temporal trends show declining share.</a:t>
             </a:r>
           </a:p>
           <a:p>
@@ -1853,7 +1853,7 @@
               <a:rPr sz="1000">
                 <a:latin typeface="Helvetica"/>
               </a:rPr>
-              <a:t>Theme 3 (Methods/AI) — 251 pubs / 2,389 projects, 18.3% pub share / 18.5% project share — is the single largest orphan in the 19→8 crosswalk. This is the empirical case for the 9th focus area.</a:t>
+              <a:t>Theme 3 (Methods/AI) — 262 pubs / 2,388 projects, 18.4% pub share / 18.5% project share — is the single largest orphan in the 19→8 crosswalk. This is the empirical case for the 9th focus area.</a:t>
             </a:r>
           </a:p>
           <a:p>
@@ -1861,7 +1861,7 @@
               <a:rPr sz="1000">
                 <a:latin typeface="Helvetica"/>
               </a:rPr>
-              <a:t>Theme 12 (Dermatology) at 14.3% share is anomalous and driven by 1–2 prolific groups per Phase 1 README; trend is declining (−3.9). Flagged on slide 18 (Caveats).</a:t>
+              <a:t>Theme 12 (Dermatology) at 13.9% share is anomalous and driven by 1–2 prolific groups per Phase 1 README; trend is declining (−4.4). Flagged on slide 18 (Caveats).</a:t>
             </a:r>
           </a:p>
           <a:p>
@@ -1950,7 +1950,7 @@
               <a:rPr sz="1000">
                 <a:latin typeface="Helvetica"/>
               </a:rPr>
-              <a:t>The crosswalk's Q6 answer in one paragraph: the 8 areas hold for disease anchoring (FA1 73%, FA8 53%, FA7 51%) but three structural problems exist — (a) theme 3 methods/AI orphan, (b) wearables orphan despite being a slide-7 priority, (c) multi-omics + imaging + AI buried in FA8 / theme 3.</a:t>
+              <a:t>The crosswalk's Q6 answer in one paragraph: the 8 areas hold for disease anchoring (FA1 74%, FA8 54%, FA7 50%) but three structural problems exist — (a) theme 3 methods/AI orphan, (b) wearables orphan despite being a slide-7 priority, (c) multi-omics + imaging + AI buried in FA8 / theme 3.</a:t>
             </a:r>
           </a:p>
           <a:p>
@@ -2047,7 +2047,7 @@
               <a:rPr sz="1000">
                 <a:latin typeface="Helvetica"/>
               </a:rPr>
-              <a:t>Wearables specifically: the trend score is +1.0 — flat in relative terms. Wearables have already matured to a permanent place in the work but the framework hasn't caught up. This is a 'recognition gap, not growth gap' — important to surface explicitly so Sci Com doesn't try to invest in something that's already steady-state.</a:t>
+              <a:t>Wearables specifically: the trend score is +0.2 — flat in relative terms. Wearables have already matured to a permanent place in the work but the framework hasn't caught up. This is a 'recognition gap, not growth gap' — important to surface explicitly so Sci Com doesn't try to invest in something that's already steady-state.</a:t>
             </a:r>
           </a:p>
         </p:txBody>
@@ -6828,7 +6828,7 @@
                 </a:solidFill>
                 <a:latin typeface="Helvetica"/>
               </a:rPr>
-              <a:t>Lecanemab/donanemab era  ↔  AoU flat at 4.2%</a:t>
+              <a:t>Lecanemab/donanemab era  ↔  AoU at 6.0% (near peer median)</a:t>
             </a:r>
           </a:p>
         </p:txBody>
@@ -6867,7 +6867,7 @@
                 </a:solidFill>
                 <a:latin typeface="Georgia"/>
               </a:rPr>
-              <a:t>Peer surge (UKB +6.0; MVP +5.7; CKB +5.4 post-2023); AoU has structural advantage but under-utilization.</a:t>
+              <a:t>Peer growth (UKB +6.9; MVP +5.4; CKB +5.1 post-2023); AoU growing (+4.7) but trailing UKB despite structural advantage.</a:t>
             </a:r>
           </a:p>
         </p:txBody>
@@ -7163,7 +7163,7 @@
                 </a:solidFill>
                 <a:latin typeface="Georgia"/>
               </a:rPr>
-              <a:t>Same-tagger keyword search across UK Biobank (5,831 pubs), FinnGen (3,075), MVP (426), and CKB (551).</a:t>
+              <a:t>Same-tagger keyword search across UK Biobank (11,868 pubs), FinnGen (3,152), MVP (438), and CKB (558) — full PubMed census.</a:t>
             </a:r>
           </a:p>
         </p:txBody>
@@ -7331,7 +7331,7 @@
         <p:spPr>
           <a:xfrm>
             <a:off x="6336792" y="1508760"/>
-            <a:ext cx="5806440" cy="2707212"/>
+            <a:ext cx="5806440" cy="2726704"/>
           </a:xfrm>
           <a:prstGeom prst="rect">
             <a:avLst/>
@@ -7926,7 +7926,7 @@
                           </a:solidFill>
                           <a:latin typeface="Georgia"/>
                         </a:rPr>
-                        <a:t>Absorbs theme 3 (18% orphan), wearables (HA2 70 pubs), AI/foundation models (HA4 31 pubs), and imaging-as-data once it flows.</a:t>
+                        <a:t>Absorbs theme 3 (18% orphan), wearables (HA2 75 pubs), AI/foundation models (HA4 33 pubs), and imaging-as-data once it flows.</a:t>
                       </a:r>
                     </a:p>
                   </a:txBody>
@@ -8043,7 +8043,7 @@
                           </a:solidFill>
                           <a:latin typeface="Georgia"/>
                         </a:rPr>
-                        <a:t>Signal that 2026 omics releases (Olink / SomaScan) have a home. UKB 12.8% post-2023 / AoU 1.9% — largest growth differential.</a:t>
+                        <a:t>Signal that 2026 omics releases (Olink / SomaScan) have a home. UKB 12.2% post-2023 / AoU 1.8% — largest growth differential.</a:t>
                       </a:r>
                     </a:p>
                   </a:txBody>
@@ -8973,7 +8973,7 @@
                           </a:solidFill>
                           <a:latin typeface="Georgia"/>
                         </a:rPr>
-                        <a:t>AoU UBR oversample as a citable diversity reference. ELSI 21.2× + SDOH 5.1× are the political-defense argument. FDA Modernization Act 2.0 creates a regulatory window.</a:t>
+                        <a:t>AoU UBR oversample as a citable diversity reference. ELSI 26.3× + SDOH 5.1× are the political-defense argument. FDA Modernization Act 2.0 creates a regulatory window.</a:t>
                       </a:r>
                     </a:p>
                   </a:txBody>
@@ -10060,7 +10060,7 @@
                 </a:solidFill>
                 <a:latin typeface="Georgia"/>
               </a:rPr>
-              <a:t>Lead: Sastry. HA4 already has 31 AI pubs (28 post-2023); the question is what AoU builds, integrates, or governs.</a:t>
+              <a:t>Lead: Sastry. HA4 already has 33 AI pubs (30 post-2023); the question is what AoU builds, integrates, or governs.</a:t>
             </a:r>
           </a:p>
         </p:txBody>
@@ -11132,7 +11132,7 @@
                           </a:solidFill>
                           <a:latin typeface="Georgia"/>
                         </a:rPr>
-                        <a:t>ELSI 21.2× + SDOH 5.1× + PGx 4.6× + methods 3.0×. Anchors the Sci Com ambassador toolkit and IC-PO briefings. "AoU scaled up everything around genomics that genomics needs to work."</a:t>
+                        <a:t>ELSI 26.3× + SDOH 5.1× + PGx 4.6× + methods 3.0×. Anchors the Sci Com ambassador toolkit and IC-PO briefings. "AoU scaled up everything around genomics that genomics needs to work."</a:t>
                       </a:r>
                     </a:p>
                   </a:txBody>
@@ -12606,7 +12606,7 @@
                 </a:solidFill>
                 <a:latin typeface="Georgia"/>
               </a:rPr>
-              <a:t>Real peer-comparative gap (AoU flat 4.2% vs UKB +6.0 / MVP +5.7 / CKB +5.4 post-2023). FLAG for WG leads; consider Tier-2 priority + WG-5 patient story.</a:t>
+              <a:t>Narrowing peer gap (AoU 6.0% post-2023, ~peer median 0.84×, trend +4.7 vs UKB +6.9 / MVP +5.4 / CKB +5.1). FLAG for WG leads; consider Tier-2 priority + WG-5 patient story.</a:t>
             </a:r>
           </a:p>
         </p:txBody>
@@ -13000,7 +13000,7 @@
                 </a:solidFill>
                 <a:latin typeface="Georgia"/>
               </a:rPr>
-              <a:t>Dermatology is 14.3% of the corpus and 7.8× the peer median — but driven by 1–2 prolific groups, not a strategic priority. Trend score −3.9 (declining share). Do NOT elevate dermatology in the Refresh even though the share index suggests it. WG-5 ambassador toolkit must have the artifact answer rehearsed.</a:t>
+              <a:t>Dermatology is 13.9% of the corpus and 6.9× the peer median — but driven by 1–2 prolific groups, not a strategic priority. Trend score −4.4 (declining share). Do NOT elevate dermatology in the Refresh even though the share index suggests it. WG-5 ambassador toolkit must have the artifact answer rehearsed.</a:t>
             </a:r>
           </a:p>
         </p:txBody>
@@ -13132,7 +13132,7 @@
                 </a:solidFill>
                 <a:latin typeface="Georgia"/>
               </a:rPr>
-              <a:t>UKB, FinnGen, MVP, and CKB corpora come from PubMed name-search with same-tagger keyword tagging. Internally consistent across peers but absolute counts under- and over-count differently. USE THE STATIC SHARE INDEX, not trend differentials, for action-relevant comparisons. MVP corpus is small (426); single-MVP signals need a second-peer corroboration.</a:t>
+              <a:t>UKB, FinnGen, MVP, and CKB corpora come from PubMed name-search with same-tagger keyword tagging — now full PubMed censuses (UKB 11,868; FinnGen 3,152; MVP 438; CKB 558). Internally consistent across peers but absolute counts under- and over-count differently. USE THE STATIC SHARE INDEX, not trend differentials, for action-relevant comparisons. MVP corpus is small (438); single-MVP signals need a second-peer corroboration.</a:t>
             </a:r>
           </a:p>
         </p:txBody>
@@ -13264,7 +13264,7 @@
                 </a:solidFill>
                 <a:latin typeface="Georgia"/>
               </a:rPr>
-              <a:t>Any active post-2023 theme will trend positive in AoU's split simply because the corpus grew ~7.8× from pre- to post-2023. Apparent 'growth' on cardiometabolic, mental health, and cancer is largely a small-baseline artifact — read as 'AoU has built a presence here,' not 'AoU is uniquely outpacing the field.' True growth signals come from the peer-comparison panel, not from the AoU-internal pre/post split.</a:t>
+              <a:t>Any active post-2023 theme will trend positive in AoU's split simply because the corpus grew ~8.1× from pre- to post-2023. Apparent 'growth' on cardiometabolic, mental health, and cancer is largely a small-baseline artifact — read as 'AoU has built a presence here,' not 'AoU is uniquely outpacing the field.' True growth signals come from the peer-comparison panel, not from the AoU-internal pre/post split.</a:t>
             </a:r>
           </a:p>
         </p:txBody>
@@ -15239,7 +15239,7 @@
                 </a:solidFill>
                 <a:latin typeface="Georgia"/>
               </a:rPr>
-              <a:t>the AoU corpus — 1,378 substantive publications + 12,899 substantive workspace projects, theme-tagged against a locked 19-theme taxonomy.</a:t>
+              <a:t>the AoU corpus — 1,428 substantive publications + 12,899 substantive workspace projects, theme-tagged against a locked 19-theme taxonomy.</a:t>
             </a:r>
           </a:p>
         </p:txBody>
@@ -16158,7 +16158,7 @@
                 </a:solidFill>
                 <a:latin typeface="Helvetica"/>
               </a:rPr>
-              <a:t>1,378</a:t>
+              <a:t>1,428</a:t>
             </a:r>
           </a:p>
         </p:txBody>
@@ -18002,7 +18002,7 @@
                 </a:solidFill>
                 <a:latin typeface="Helvetica"/>
               </a:rPr>
-              <a:t>27.8%</a:t>
+              <a:t>28.4%</a:t>
             </a:r>
           </a:p>
         </p:txBody>
@@ -18163,7 +18163,7 @@
                 </a:solidFill>
                 <a:latin typeface="Helvetica"/>
               </a:rPr>
-              <a:t>25.3%</a:t>
+              <a:t>24.9%</a:t>
             </a:r>
           </a:p>
         </p:txBody>
@@ -18324,7 +18324,7 @@
                 </a:solidFill>
                 <a:latin typeface="Helvetica"/>
               </a:rPr>
-              <a:t>18.3%</a:t>
+              <a:t>18.4%</a:t>
             </a:r>
           </a:p>
         </p:txBody>
@@ -18485,7 +18485,7 @@
                 </a:solidFill>
                 <a:latin typeface="Helvetica"/>
               </a:rPr>
-              <a:t>18.5%</a:t>
+              <a:t>18.8%</a:t>
             </a:r>
           </a:p>
         </p:txBody>
@@ -18807,7 +18807,7 @@
                 </a:solidFill>
                 <a:latin typeface="Helvetica"/>
               </a:rPr>
-              <a:t>33.3%</a:t>
+              <a:t>32.9%</a:t>
             </a:r>
           </a:p>
         </p:txBody>
@@ -18968,7 +18968,7 @@
                 </a:solidFill>
                 <a:latin typeface="Helvetica"/>
               </a:rPr>
-              <a:t>5.3%</a:t>
+              <a:t>5.4%</a:t>
             </a:r>
           </a:p>
         </p:txBody>
@@ -19129,7 +19129,7 @@
                 </a:solidFill>
                 <a:latin typeface="Helvetica"/>
               </a:rPr>
-              <a:t>5.8%</a:t>
+              <a:t>6.0%</a:t>
             </a:r>
           </a:p>
         </p:txBody>
@@ -19290,7 +19290,7 @@
                 </a:solidFill>
                 <a:latin typeface="Helvetica"/>
               </a:rPr>
-              <a:t>7.8%</a:t>
+              <a:t>7.6%</a:t>
             </a:r>
           </a:p>
         </p:txBody>
@@ -19451,7 +19451,7 @@
                 </a:solidFill>
                 <a:latin typeface="Helvetica"/>
               </a:rPr>
-              <a:t>3.9%</a:t>
+              <a:t>3.8%</a:t>
             </a:r>
           </a:p>
         </p:txBody>
@@ -19773,7 +19773,7 @@
                 </a:solidFill>
                 <a:latin typeface="Helvetica"/>
               </a:rPr>
-              <a:t>14.3%</a:t>
+              <a:t>13.9%</a:t>
             </a:r>
           </a:p>
         </p:txBody>
@@ -19934,7 +19934,7 @@
                 </a:solidFill>
                 <a:latin typeface="Helvetica"/>
               </a:rPr>
-              <a:t>4.3%</a:t>
+              <a:t>4.2%</a:t>
             </a:r>
           </a:p>
         </p:txBody>
@@ -20095,7 +20095,7 @@
                 </a:solidFill>
                 <a:latin typeface="Helvetica"/>
               </a:rPr>
-              <a:t>5.6%</a:t>
+              <a:t>5.7%</a:t>
             </a:r>
           </a:p>
         </p:txBody>
@@ -20417,7 +20417,7 @@
                 </a:solidFill>
                 <a:latin typeface="Helvetica"/>
               </a:rPr>
-              <a:t>2.3%</a:t>
+              <a:t>2.4%</a:t>
             </a:r>
           </a:p>
         </p:txBody>
@@ -20578,7 +20578,7 @@
                 </a:solidFill>
                 <a:latin typeface="Helvetica"/>
               </a:rPr>
-              <a:t>5.0%</a:t>
+              <a:t>4.9%</a:t>
             </a:r>
           </a:p>
         </p:txBody>
@@ -20739,7 +20739,7 @@
                 </a:solidFill>
                 <a:latin typeface="Helvetica"/>
               </a:rPr>
-              <a:t>7.8%</a:t>
+              <a:t>7.6%</a:t>
             </a:r>
           </a:p>
         </p:txBody>
@@ -20900,7 +20900,7 @@
                 </a:solidFill>
                 <a:latin typeface="Helvetica"/>
               </a:rPr>
-              <a:t>0.5%</a:t>
+              <a:t>0.6%</a:t>
             </a:r>
           </a:p>
         </p:txBody>
@@ -21459,7 +21459,7 @@
                 </a:solidFill>
                 <a:latin typeface="Georgia"/>
               </a:rPr>
-              <a:t>18% of substantive pubs (251) and 19% of projects (2,389) have NO clean home in the 8-area framework.</a:t>
+              <a:t>18% of substantive pubs (262) and 19% of projects (2,388) have NO clean home in the 8-area framework.</a:t>
             </a:r>
           </a:p>
           <a:p>
@@ -21487,7 +21487,7 @@
                 </a:solidFill>
                 <a:latin typeface="Georgia"/>
               </a:rPr>
-              <a:t>Includes the AI/foundation-model surge (HA4: 31 pubs, 28 post-2023), workbench tooling, EHR phenotyping, federated learning.</a:t>
+              <a:t>Includes the AI/foundation-model surge (HA4: 33 pubs, 30 post-2023), workbench tooling, EHR phenotyping, federated learning.</a:t>
             </a:r>
           </a:p>
           <a:p>
@@ -21734,7 +21734,7 @@
                 </a:solidFill>
                 <a:latin typeface="Georgia"/>
               </a:rPr>
-              <a:t>70 pubs (5.3% share) — slide-7 priority that has nowhere to live in the 8 areas.</a:t>
+              <a:t>75 pubs (5.4% share) — slide-7 priority that has nowhere to live in the 8 areas.</a:t>
             </a:r>
           </a:p>
           <a:p>
@@ -21762,7 +21762,7 @@
                 </a:solidFill>
                 <a:latin typeface="Georgia"/>
               </a:rPr>
-              <a:t>Trend is flat (+1.0) — wearables have already MATURED, not emerging. Important reframe.</a:t>
+              <a:t>Trend is flat (+0.2) — wearables have already MATURED, not emerging. Important reframe.</a:t>
             </a:r>
           </a:p>
           <a:p>
@@ -22065,7 +22065,7 @@
                 </a:solidFill>
                 <a:latin typeface="Georgia"/>
               </a:rPr>
-              <a:t>Largest peer-comparative growth differential: UKB 12.8% post-2023 vs AoU 1.9%. 2026 omics releases need a NAMED home.</a:t>
+              <a:t>Largest peer-comparative growth differential: UKB 12.2% post-2023 vs AoU 1.8%. 2026 omics releases need a NAMED home.</a:t>
             </a:r>
           </a:p>
         </p:txBody>
@@ -22619,7 +22619,7 @@
                 </a:solidFill>
                 <a:latin typeface="Helvetica"/>
               </a:rPr>
-              <a:t>31 pubs (HA4); 28 post-2023</a:t>
+              <a:t>33 pubs (HA4); 30 post-2023</a:t>
             </a:r>
           </a:p>
         </p:txBody>
@@ -22865,7 +22865,7 @@
                 </a:solidFill>
                 <a:latin typeface="Helvetica"/>
               </a:rPr>
-              <a:t>16 pubs (HA8); 15 post-2023</a:t>
+              <a:t>20 pubs (HA8); 19 post-2023</a:t>
             </a:r>
           </a:p>
         </p:txBody>
@@ -23111,7 +23111,7 @@
                 </a:solidFill>
                 <a:latin typeface="Helvetica"/>
               </a:rPr>
-              <a:t>70 pubs (HA2); 62 post-2023; trend flat</a:t>
+              <a:t>75 pubs (HA2); 67 post-2023; trend flat</a:t>
             </a:r>
           </a:p>
         </p:txBody>
@@ -23357,7 +23357,7 @@
                 </a:solidFill>
                 <a:latin typeface="Helvetica"/>
               </a:rPr>
-              <a:t>10 pubs (HA6); 0 pre-2023</a:t>
+              <a:t>11 pubs (HA6); 0 pre-2023</a:t>
             </a:r>
           </a:p>
         </p:txBody>
@@ -23943,7 +23943,7 @@
                 </a:solidFill>
                 <a:latin typeface="Georgia"/>
               </a:rPr>
-              <a:t>→ UKB 12.8% post-2023 / AoU 1.9% — largest growth differential. 2026 release closes mechanically.</a:t>
+              <a:t>→ UKB 12.2% post-2023 / AoU 1.8% — largest growth differential. 2026 release closes mechanically.</a:t>
             </a:r>
           </a:p>
         </p:txBody>
@@ -24435,7 +24435,7 @@
                 </a:solidFill>
                 <a:latin typeface="Georgia"/>
               </a:rPr>
-              <a:t>→ UKB 10.4% / FinnGen 15.1% post-2023 / AoU 0.8%. Requires sample-collection decision.</a:t>
+              <a:t>→ UKB 11.3% / FinnGen 14.6% post-2023 / AoU 0.8%. Requires sample-collection decision.</a:t>
             </a:r>
           </a:p>
         </p:txBody>
@@ -24603,7 +24603,7 @@
                 </a:solidFill>
                 <a:latin typeface="Helvetica"/>
               </a:rPr>
-              <a:t>12 pubs (HA5); 7 substantive (theme 19)</a:t>
+              <a:t>13 pubs (HA5); 8 substantive (theme 19)</a:t>
             </a:r>
           </a:p>
         </p:txBody>
@@ -25150,7 +25150,7 @@
                           </a:solidFill>
                           <a:latin typeface="Georgia"/>
                         </a:rPr>
-                        <a:t>Goal 7 literally describes the AoU mandate. AoU 33.3% SDOH share; 5.1× peer median.</a:t>
+                        <a:t>Goal 7 literally describes the AoU mandate. AoU 32.9% SDOH share; 5.1× peer median.</a:t>
                       </a:r>
                     </a:p>
                   </a:txBody>
@@ -25221,7 +25221,7 @@
                           </a:solidFill>
                           <a:latin typeface="Georgia"/>
                         </a:rPr>
-                        <a:t>The only IC plan that explicitly names All of Us. Theme 3: 251 pubs, 2,389 projects.</a:t>
+                        <a:t>The only IC plan that explicitly names All of Us. Theme 3: 262 pubs, 2,388 projects.</a:t>
                       </a:r>
                     </a:p>
                   </a:txBody>

</xml_diff>